<commit_message>
Changed folder structure and created first version of final paper
</commit_message>
<xml_diff>
--- a/figures/IPEC_Figure_AirGap.pptx
+++ b/figures/IPEC_Figure_AirGap.pptx
@@ -1,6 +1,6 @@
 
 <file path=ppt/presentation.xml><?xml version="1.0" encoding="utf-8"?>
-<p:presentation xmlns:a="http://schemas.openxmlformats.org/drawingml/2006/main" xmlns:r="http://schemas.openxmlformats.org/officeDocument/2006/relationships" xmlns:p="http://schemas.openxmlformats.org/presentationml/2006/main" saveSubsetFonts="1">
+<p:presentation xmlns:a="http://schemas.openxmlformats.org/drawingml/2006/main" xmlns:r="http://schemas.openxmlformats.org/officeDocument/2006/relationships" xmlns:p="http://schemas.openxmlformats.org/presentationml/2006/main" embedTrueTypeFonts="1" saveSubsetFonts="1">
   <p:sldMasterIdLst>
     <p:sldMasterId id="2147483674" r:id="rId1"/>
   </p:sldMasterIdLst>
@@ -197,7 +197,7 @@
           <a:p>
             <a:fld id="{E12D018B-8A23-4312-B28B-6340BA8214C1}" type="datetimeFigureOut">
               <a:rPr lang="de-DE" smtClean="0"/>
-              <a:t>15.10.2025</a:t>
+              <a:t>19.02.2026</a:t>
             </a:fld>
             <a:endParaRPr lang="de-DE"/>
           </a:p>
@@ -721,7 +721,7 @@
           <a:p>
             <a:fld id="{ECCFC019-03F5-4F01-A944-8CA3CB0F4BCD}" type="datetimeFigureOut">
               <a:rPr lang="de-DE" smtClean="0"/>
-              <a:t>15.10.2025</a:t>
+              <a:t>19.02.2026</a:t>
             </a:fld>
             <a:endParaRPr lang="de-DE"/>
           </a:p>
@@ -891,7 +891,7 @@
           <a:p>
             <a:fld id="{ECCFC019-03F5-4F01-A944-8CA3CB0F4BCD}" type="datetimeFigureOut">
               <a:rPr lang="de-DE" smtClean="0"/>
-              <a:t>15.10.2025</a:t>
+              <a:t>19.02.2026</a:t>
             </a:fld>
             <a:endParaRPr lang="de-DE"/>
           </a:p>
@@ -1071,7 +1071,7 @@
           <a:p>
             <a:fld id="{ECCFC019-03F5-4F01-A944-8CA3CB0F4BCD}" type="datetimeFigureOut">
               <a:rPr lang="de-DE" smtClean="0"/>
-              <a:t>15.10.2025</a:t>
+              <a:t>19.02.2026</a:t>
             </a:fld>
             <a:endParaRPr lang="de-DE"/>
           </a:p>
@@ -1549,7 +1549,7 @@
           <a:p>
             <a:fld id="{ECCFC019-03F5-4F01-A944-8CA3CB0F4BCD}" type="datetimeFigureOut">
               <a:rPr lang="de-DE" smtClean="0"/>
-              <a:t>15.10.2025</a:t>
+              <a:t>19.02.2026</a:t>
             </a:fld>
             <a:endParaRPr lang="de-DE"/>
           </a:p>
@@ -1795,7 +1795,7 @@
           <a:p>
             <a:fld id="{ECCFC019-03F5-4F01-A944-8CA3CB0F4BCD}" type="datetimeFigureOut">
               <a:rPr lang="de-DE" smtClean="0"/>
-              <a:t>15.10.2025</a:t>
+              <a:t>19.02.2026</a:t>
             </a:fld>
             <a:endParaRPr lang="de-DE"/>
           </a:p>
@@ -2027,7 +2027,7 @@
           <a:p>
             <a:fld id="{ECCFC019-03F5-4F01-A944-8CA3CB0F4BCD}" type="datetimeFigureOut">
               <a:rPr lang="de-DE" smtClean="0"/>
-              <a:t>15.10.2025</a:t>
+              <a:t>19.02.2026</a:t>
             </a:fld>
             <a:endParaRPr lang="de-DE"/>
           </a:p>
@@ -2394,7 +2394,7 @@
           <a:p>
             <a:fld id="{ECCFC019-03F5-4F01-A944-8CA3CB0F4BCD}" type="datetimeFigureOut">
               <a:rPr lang="de-DE" smtClean="0"/>
-              <a:t>15.10.2025</a:t>
+              <a:t>19.02.2026</a:t>
             </a:fld>
             <a:endParaRPr lang="de-DE"/>
           </a:p>
@@ -2512,7 +2512,7 @@
           <a:p>
             <a:fld id="{ECCFC019-03F5-4F01-A944-8CA3CB0F4BCD}" type="datetimeFigureOut">
               <a:rPr lang="de-DE" smtClean="0"/>
-              <a:t>15.10.2025</a:t>
+              <a:t>19.02.2026</a:t>
             </a:fld>
             <a:endParaRPr lang="de-DE"/>
           </a:p>
@@ -2607,7 +2607,7 @@
           <a:p>
             <a:fld id="{ECCFC019-03F5-4F01-A944-8CA3CB0F4BCD}" type="datetimeFigureOut">
               <a:rPr lang="de-DE" smtClean="0"/>
-              <a:t>15.10.2025</a:t>
+              <a:t>19.02.2026</a:t>
             </a:fld>
             <a:endParaRPr lang="de-DE"/>
           </a:p>
@@ -2884,7 +2884,7 @@
           <a:p>
             <a:fld id="{ECCFC019-03F5-4F01-A944-8CA3CB0F4BCD}" type="datetimeFigureOut">
               <a:rPr lang="de-DE" smtClean="0"/>
-              <a:t>15.10.2025</a:t>
+              <a:t>19.02.2026</a:t>
             </a:fld>
             <a:endParaRPr lang="de-DE"/>
           </a:p>
@@ -3141,7 +3141,7 @@
           <a:p>
             <a:fld id="{ECCFC019-03F5-4F01-A944-8CA3CB0F4BCD}" type="datetimeFigureOut">
               <a:rPr lang="de-DE" smtClean="0"/>
-              <a:t>15.10.2025</a:t>
+              <a:t>19.02.2026</a:t>
             </a:fld>
             <a:endParaRPr lang="de-DE"/>
           </a:p>
@@ -3354,7 +3354,7 @@
           <a:p>
             <a:fld id="{ECCFC019-03F5-4F01-A944-8CA3CB0F4BCD}" type="datetimeFigureOut">
               <a:rPr lang="de-DE" smtClean="0"/>
-              <a:t>15.10.2025</a:t>
+              <a:t>19.02.2026</a:t>
             </a:fld>
             <a:endParaRPr lang="de-DE"/>
           </a:p>

</xml_diff>